<commit_message>
Update file because i push wrong file. Soryy about that.
</commit_message>
<xml_diff>
--- a/final/ML-in-Medicine.pptx
+++ b/final/ML-in-Medicine.pptx
@@ -257,7 +257,7 @@
           <a:p>
             <a:fld id="{B7268E1E-0E44-426D-905E-8AD9B19D2182}" type="datetimeFigureOut">
               <a:rPr lang="cs-CZ" smtClean="0"/>
-              <a:t>10.03.2026</a:t>
+              <a:t>16.03.2026</a:t>
             </a:fld>
             <a:endParaRPr lang="cs-CZ"/>
           </a:p>
@@ -923,7 +923,7 @@
             <a:fld id="{1D8BD707-D9CF-40AE-B4C6-C98DA3205C09}" type="datetimeFigureOut">
               <a:rPr lang="en-US" smtClean="0"/>
               <a:pPr/>
-              <a:t>3/10/2026</a:t>
+              <a:t>3/16/2026</a:t>
             </a:fld>
             <a:endParaRPr lang="en-US"/>
           </a:p>
@@ -1088,7 +1088,7 @@
             <a:fld id="{1D8BD707-D9CF-40AE-B4C6-C98DA3205C09}" type="datetimeFigureOut">
               <a:rPr lang="en-US" smtClean="0"/>
               <a:pPr/>
-              <a:t>3/10/2026</a:t>
+              <a:t>3/16/2026</a:t>
             </a:fld>
             <a:endParaRPr lang="en-US"/>
           </a:p>
@@ -1263,7 +1263,7 @@
             <a:fld id="{1D8BD707-D9CF-40AE-B4C6-C98DA3205C09}" type="datetimeFigureOut">
               <a:rPr lang="en-US" smtClean="0"/>
               <a:pPr/>
-              <a:t>3/10/2026</a:t>
+              <a:t>3/16/2026</a:t>
             </a:fld>
             <a:endParaRPr lang="en-US"/>
           </a:p>
@@ -1428,7 +1428,7 @@
             <a:fld id="{1D8BD707-D9CF-40AE-B4C6-C98DA3205C09}" type="datetimeFigureOut">
               <a:rPr lang="en-US" smtClean="0"/>
               <a:pPr/>
-              <a:t>3/10/2026</a:t>
+              <a:t>3/16/2026</a:t>
             </a:fld>
             <a:endParaRPr lang="en-US"/>
           </a:p>
@@ -1670,7 +1670,7 @@
             <a:fld id="{1D8BD707-D9CF-40AE-B4C6-C98DA3205C09}" type="datetimeFigureOut">
               <a:rPr lang="en-US" smtClean="0"/>
               <a:pPr/>
-              <a:t>3/10/2026</a:t>
+              <a:t>3/16/2026</a:t>
             </a:fld>
             <a:endParaRPr lang="en-US"/>
           </a:p>
@@ -1952,7 +1952,7 @@
             <a:fld id="{1D8BD707-D9CF-40AE-B4C6-C98DA3205C09}" type="datetimeFigureOut">
               <a:rPr lang="en-US" smtClean="0"/>
               <a:pPr/>
-              <a:t>3/10/2026</a:t>
+              <a:t>3/16/2026</a:t>
             </a:fld>
             <a:endParaRPr lang="en-US"/>
           </a:p>
@@ -2368,7 +2368,7 @@
             <a:fld id="{1D8BD707-D9CF-40AE-B4C6-C98DA3205C09}" type="datetimeFigureOut">
               <a:rPr lang="en-US" smtClean="0"/>
               <a:pPr/>
-              <a:t>3/10/2026</a:t>
+              <a:t>3/16/2026</a:t>
             </a:fld>
             <a:endParaRPr lang="en-US"/>
           </a:p>
@@ -2482,7 +2482,7 @@
             <a:fld id="{1D8BD707-D9CF-40AE-B4C6-C98DA3205C09}" type="datetimeFigureOut">
               <a:rPr lang="en-US" smtClean="0"/>
               <a:pPr/>
-              <a:t>3/10/2026</a:t>
+              <a:t>3/16/2026</a:t>
             </a:fld>
             <a:endParaRPr lang="en-US"/>
           </a:p>
@@ -2574,7 +2574,7 @@
             <a:fld id="{1D8BD707-D9CF-40AE-B4C6-C98DA3205C09}" type="datetimeFigureOut">
               <a:rPr lang="en-US" smtClean="0"/>
               <a:pPr/>
-              <a:t>3/10/2026</a:t>
+              <a:t>3/16/2026</a:t>
             </a:fld>
             <a:endParaRPr lang="en-US"/>
           </a:p>
@@ -2846,7 +2846,7 @@
             <a:fld id="{1D8BD707-D9CF-40AE-B4C6-C98DA3205C09}" type="datetimeFigureOut">
               <a:rPr lang="en-US" smtClean="0"/>
               <a:pPr/>
-              <a:t>3/10/2026</a:t>
+              <a:t>3/16/2026</a:t>
             </a:fld>
             <a:endParaRPr lang="en-US"/>
           </a:p>
@@ -3095,7 +3095,7 @@
             <a:fld id="{1D8BD707-D9CF-40AE-B4C6-C98DA3205C09}" type="datetimeFigureOut">
               <a:rPr lang="en-US" smtClean="0"/>
               <a:pPr/>
-              <a:t>3/10/2026</a:t>
+              <a:t>3/16/2026</a:t>
             </a:fld>
             <a:endParaRPr lang="en-US"/>
           </a:p>
@@ -3303,7 +3303,7 @@
             <a:fld id="{1D8BD707-D9CF-40AE-B4C6-C98DA3205C09}" type="datetimeFigureOut">
               <a:rPr lang="en-US" smtClean="0"/>
               <a:pPr/>
-              <a:t>3/10/2026</a:t>
+              <a:t>3/16/2026</a:t>
             </a:fld>
             <a:endParaRPr lang="en-US"/>
           </a:p>
@@ -5817,7 +5817,7 @@
                 <a:cs typeface="Barlow"/>
                 <a:sym typeface="Barlow"/>
               </a:rPr>
-              <a:t> Improve regression loss design</a:t>
+              <a:t>Improve regression loss design</a:t>
             </a:r>
           </a:p>
           <a:p>
@@ -11604,8 +11604,8 @@
         </p:nvSpPr>
         <p:spPr>
           <a:xfrm>
-            <a:off x="6728838" y="6431130"/>
-            <a:ext cx="3313191" cy="903597"/>
+            <a:off x="6101633" y="6507512"/>
+            <a:ext cx="1594568" cy="732117"/>
           </a:xfrm>
           <a:custGeom>
             <a:avLst/>
@@ -11788,7 +11788,7 @@
         <p:spPr>
           <a:xfrm>
             <a:off x="1028700" y="6383687"/>
-            <a:ext cx="6545155" cy="2171700"/>
+            <a:ext cx="6545155" cy="2251129"/>
           </a:xfrm>
           <a:prstGeom prst="rect">
             <a:avLst/>
@@ -11802,7 +11802,7 @@
           <a:p>
             <a:pPr algn="l">
               <a:lnSpc>
-                <a:spcPts val="5999"/>
+                <a:spcPct val="150000"/>
               </a:lnSpc>
             </a:pPr>
             <a:r>
@@ -11821,13 +11821,13 @@
           <a:p>
             <a:pPr marL="647700" lvl="1" indent="-323850" algn="l">
               <a:lnSpc>
-                <a:spcPts val="6000"/>
+                <a:spcPct val="150000"/>
               </a:lnSpc>
               <a:buFont typeface="Arial"/>
               <a:buChar char="•"/>
             </a:pPr>
             <a:r>
-              <a:rPr lang="en-US" sz="3000" dirty="0">
+              <a:rPr lang="en-US" sz="2000" dirty="0">
                 <a:solidFill>
                   <a:srgbClr val="000000"/>
                 </a:solidFill>
@@ -11836,19 +11836,38 @@
                 <a:cs typeface="Barlow"/>
                 <a:sym typeface="Barlow"/>
               </a:rPr>
-              <a:t>Convert images → RGB (3 channels)</a:t>
+              <a:t>Convert images </a:t>
+            </a:r>
+          </a:p>
+          <a:p>
+            <a:pPr marL="323850" lvl="1" algn="l">
+              <a:lnSpc>
+                <a:spcPct val="150000"/>
+              </a:lnSpc>
+            </a:pPr>
+            <a:r>
+              <a:rPr lang="en-US" sz="2000" dirty="0">
+                <a:solidFill>
+                  <a:srgbClr val="000000"/>
+                </a:solidFill>
+                <a:latin typeface="Barlow"/>
+                <a:ea typeface="Barlow"/>
+                <a:cs typeface="Barlow"/>
+                <a:sym typeface="Barlow"/>
+              </a:rPr>
+              <a:t>     → RGB (3 channels)</a:t>
             </a:r>
           </a:p>
           <a:p>
             <a:pPr marL="647700" lvl="1" indent="-323850" algn="l">
               <a:lnSpc>
-                <a:spcPts val="6000"/>
+                <a:spcPct val="150000"/>
               </a:lnSpc>
               <a:buFont typeface="Arial"/>
               <a:buChar char="•"/>
             </a:pPr>
             <a:r>
-              <a:rPr lang="en-US" sz="3000" dirty="0">
+              <a:rPr lang="en-US" sz="2000" dirty="0">
                 <a:solidFill>
                   <a:srgbClr val="000000"/>
                 </a:solidFill>
@@ -11870,26 +11889,26 @@
         </p:nvSpPr>
         <p:spPr>
           <a:xfrm>
-            <a:off x="10714145" y="6383687"/>
-            <a:ext cx="6545155" cy="2171700"/>
+            <a:off x="7924800" y="6383687"/>
+            <a:ext cx="10112183" cy="3167342"/>
           </a:xfrm>
           <a:prstGeom prst="rect">
             <a:avLst/>
           </a:prstGeom>
         </p:spPr>
         <p:txBody>
-          <a:bodyPr lIns="0" tIns="0" rIns="0" bIns="0" rtlCol="0" anchor="t">
+          <a:bodyPr wrap="square" lIns="0" tIns="0" rIns="0" bIns="0" rtlCol="0" anchor="t">
             <a:spAutoFit/>
           </a:bodyPr>
           <a:lstStyle/>
           <a:p>
             <a:pPr algn="l">
               <a:lnSpc>
-                <a:spcPts val="5999"/>
+                <a:spcPct val="150000"/>
               </a:lnSpc>
             </a:pPr>
             <a:r>
-              <a:rPr lang="en-US" sz="3999" b="1">
+              <a:rPr lang="en-US" sz="3999" b="1" dirty="0">
                 <a:solidFill>
                   <a:srgbClr val="000000"/>
                 </a:solidFill>
@@ -11904,13 +11923,13 @@
           <a:p>
             <a:pPr marL="647700" lvl="1" indent="-323850" algn="l">
               <a:lnSpc>
-                <a:spcPts val="6000"/>
+                <a:spcPct val="150000"/>
               </a:lnSpc>
               <a:buFont typeface="Arial"/>
               <a:buChar char="•"/>
             </a:pPr>
             <a:r>
-              <a:rPr lang="en-US" sz="3000">
+              <a:rPr lang="en-US" sz="2000" dirty="0">
                 <a:solidFill>
                   <a:srgbClr val="000000"/>
                 </a:solidFill>
@@ -11919,19 +11938,43 @@
                 <a:cs typeface="Barlow"/>
                 <a:sym typeface="Barlow"/>
               </a:rPr>
-              <a:t>YOLO bbox + polygon labels</a:t>
+              <a:t>YOLO </a:t>
+            </a:r>
+            <a:r>
+              <a:rPr lang="en-US" sz="2000" dirty="0" err="1">
+                <a:solidFill>
+                  <a:srgbClr val="000000"/>
+                </a:solidFill>
+                <a:latin typeface="Barlow"/>
+                <a:ea typeface="Barlow"/>
+                <a:cs typeface="Barlow"/>
+                <a:sym typeface="Barlow"/>
+              </a:rPr>
+              <a:t>bbox</a:t>
+            </a:r>
+            <a:r>
+              <a:rPr lang="en-US" sz="2000" dirty="0">
+                <a:solidFill>
+                  <a:srgbClr val="000000"/>
+                </a:solidFill>
+                <a:latin typeface="Barlow"/>
+                <a:ea typeface="Barlow"/>
+                <a:cs typeface="Barlow"/>
+                <a:sym typeface="Barlow"/>
+              </a:rPr>
+              <a:t> + polygon labels</a:t>
             </a:r>
           </a:p>
           <a:p>
             <a:pPr marL="647700" lvl="1" indent="-323850" algn="l">
               <a:lnSpc>
-                <a:spcPts val="6000"/>
+                <a:spcPct val="150000"/>
               </a:lnSpc>
               <a:buFont typeface="Arial"/>
               <a:buChar char="•"/>
             </a:pPr>
             <a:r>
-              <a:rPr lang="en-US" sz="3000">
+              <a:rPr lang="en-US" sz="2000" dirty="0">
                 <a:solidFill>
                   <a:srgbClr val="000000"/>
                 </a:solidFill>
@@ -11941,6 +11984,123 @@
                 <a:sym typeface="Barlow"/>
               </a:rPr>
               <a:t>Convert all → bounding boxes</a:t>
+            </a:r>
+          </a:p>
+          <a:p>
+            <a:pPr marL="647700" lvl="1" indent="-323850">
+              <a:lnSpc>
+                <a:spcPct val="150000"/>
+              </a:lnSpc>
+              <a:buFont typeface="Arial"/>
+              <a:buChar char="•"/>
+            </a:pPr>
+            <a:r>
+              <a:rPr lang="en-US" sz="2000" dirty="0">
+                <a:solidFill>
+                  <a:srgbClr val="000000"/>
+                </a:solidFill>
+                <a:latin typeface="Barlow"/>
+                <a:ea typeface="Barlow"/>
+                <a:cs typeface="Barlow"/>
+                <a:sym typeface="Barlow"/>
+              </a:rPr>
+              <a:t>Eg: 0 0.27071744999999997 0 0.25350870625 0.08854474062499999 0.3339921703125 0.53257750625 1 0.47395911875 → </a:t>
+            </a:r>
+            <a:r>
+              <a:rPr lang="en-US" sz="2000" dirty="0" err="1">
+                <a:solidFill>
+                  <a:srgbClr val="000000"/>
+                </a:solidFill>
+                <a:latin typeface="Barlow"/>
+                <a:ea typeface="Barlow"/>
+                <a:cs typeface="Barlow"/>
+                <a:sym typeface="Barlow"/>
+              </a:rPr>
+              <a:t>x_min</a:t>
+            </a:r>
+            <a:r>
+              <a:rPr lang="en-US" sz="2000" dirty="0">
+                <a:solidFill>
+                  <a:srgbClr val="000000"/>
+                </a:solidFill>
+                <a:latin typeface="Barlow"/>
+                <a:ea typeface="Barlow"/>
+                <a:cs typeface="Barlow"/>
+                <a:sym typeface="Barlow"/>
+              </a:rPr>
+              <a:t> = 0; </a:t>
+            </a:r>
+            <a:r>
+              <a:rPr lang="en-US" sz="2000" dirty="0" err="1">
+                <a:solidFill>
+                  <a:srgbClr val="000000"/>
+                </a:solidFill>
+                <a:latin typeface="Barlow"/>
+                <a:ea typeface="Barlow"/>
+                <a:cs typeface="Barlow"/>
+                <a:sym typeface="Barlow"/>
+              </a:rPr>
+              <a:t>y_min</a:t>
+            </a:r>
+            <a:r>
+              <a:rPr lang="en-US" sz="2000" dirty="0">
+                <a:solidFill>
+                  <a:srgbClr val="000000"/>
+                </a:solidFill>
+                <a:latin typeface="Barlow"/>
+                <a:ea typeface="Barlow"/>
+                <a:cs typeface="Barlow"/>
+                <a:sym typeface="Barlow"/>
+              </a:rPr>
+              <a:t> = 0.25350870625; </a:t>
+            </a:r>
+            <a:r>
+              <a:rPr lang="en-US" sz="2000" dirty="0" err="1">
+                <a:solidFill>
+                  <a:srgbClr val="000000"/>
+                </a:solidFill>
+                <a:latin typeface="Barlow"/>
+                <a:ea typeface="Barlow"/>
+                <a:cs typeface="Barlow"/>
+                <a:sym typeface="Barlow"/>
+              </a:rPr>
+              <a:t>x_max</a:t>
+            </a:r>
+            <a:r>
+              <a:rPr lang="en-US" sz="2000" dirty="0">
+                <a:solidFill>
+                  <a:srgbClr val="000000"/>
+                </a:solidFill>
+                <a:latin typeface="Barlow"/>
+                <a:ea typeface="Barlow"/>
+                <a:cs typeface="Barlow"/>
+                <a:sym typeface="Barlow"/>
+              </a:rPr>
+              <a:t>  = 0.53257750625; </a:t>
+            </a:r>
+            <a:r>
+              <a:rPr lang="en-US" sz="2000" dirty="0" err="1">
+                <a:solidFill>
+                  <a:srgbClr val="000000"/>
+                </a:solidFill>
+                <a:latin typeface="Barlow"/>
+                <a:ea typeface="Barlow"/>
+                <a:cs typeface="Barlow"/>
+                <a:sym typeface="Barlow"/>
+              </a:rPr>
+              <a:t>y_max</a:t>
+            </a:r>
+            <a:r>
+              <a:rPr lang="en-US" sz="2000" dirty="0">
+                <a:solidFill>
+                  <a:srgbClr val="000000"/>
+                </a:solidFill>
+                <a:latin typeface="Barlow"/>
+                <a:ea typeface="Barlow"/>
+                <a:cs typeface="Barlow"/>
+                <a:sym typeface="Barlow"/>
+              </a:rPr>
+              <a:t> = 1</a:t>
             </a:r>
           </a:p>
         </p:txBody>
@@ -12006,7 +12166,7 @@
         <p:spPr>
           <a:xfrm>
             <a:off x="1028700" y="6383687"/>
-            <a:ext cx="6545155" cy="2933700"/>
+            <a:ext cx="6545155" cy="2244012"/>
           </a:xfrm>
           <a:prstGeom prst="rect">
             <a:avLst/>
@@ -12020,7 +12180,7 @@
           <a:p>
             <a:pPr algn="l">
               <a:lnSpc>
-                <a:spcPts val="5999"/>
+                <a:spcPct val="150000"/>
               </a:lnSpc>
             </a:pPr>
             <a:r>
@@ -12039,13 +12199,13 @@
           <a:p>
             <a:pPr marL="647700" lvl="1" indent="-323850" algn="l">
               <a:lnSpc>
-                <a:spcPts val="6000"/>
+                <a:spcPct val="150000"/>
               </a:lnSpc>
               <a:buFont typeface="Arial"/>
               <a:buChar char="•"/>
             </a:pPr>
             <a:r>
-              <a:rPr lang="en-US" sz="3000" dirty="0">
+              <a:rPr lang="en-US" sz="2000" dirty="0">
                 <a:solidFill>
                   <a:srgbClr val="000000"/>
                 </a:solidFill>
@@ -12060,13 +12220,13 @@
           <a:p>
             <a:pPr marL="647700" lvl="1" indent="-323850" algn="l">
               <a:lnSpc>
-                <a:spcPts val="6000"/>
+                <a:spcPct val="150000"/>
               </a:lnSpc>
               <a:buFont typeface="Arial"/>
               <a:buChar char="•"/>
             </a:pPr>
             <a:r>
-              <a:rPr lang="en-US" sz="3000" dirty="0">
+              <a:rPr lang="en-US" sz="2000" dirty="0">
                 <a:solidFill>
                   <a:srgbClr val="000000"/>
                 </a:solidFill>
@@ -12081,13 +12241,13 @@
           <a:p>
             <a:pPr marL="647700" lvl="1" indent="-323850" algn="l">
               <a:lnSpc>
-                <a:spcPts val="6000"/>
+                <a:spcPct val="150000"/>
               </a:lnSpc>
               <a:buFont typeface="Arial"/>
               <a:buChar char="•"/>
             </a:pPr>
             <a:r>
-              <a:rPr lang="en-US" sz="3000" dirty="0">
+              <a:rPr lang="en-US" sz="2000" dirty="0">
                 <a:solidFill>
                   <a:srgbClr val="000000"/>
                 </a:solidFill>
@@ -12109,8 +12269,8 @@
         </p:nvSpPr>
         <p:spPr>
           <a:xfrm>
-            <a:off x="7400244" y="6337851"/>
-            <a:ext cx="10195061" cy="2933700"/>
+            <a:off x="7924800" y="6507512"/>
+            <a:ext cx="10195061" cy="1628651"/>
           </a:xfrm>
           <a:prstGeom prst="rect">
             <a:avLst/>
@@ -12128,7 +12288,7 @@
               </a:lnSpc>
             </a:pPr>
             <a:r>
-              <a:rPr lang="en-US" sz="3999" b="1">
+              <a:rPr lang="en-US" sz="3999" b="1" dirty="0">
                 <a:solidFill>
                   <a:srgbClr val="000000"/>
                 </a:solidFill>
@@ -12143,34 +12303,13 @@
           <a:p>
             <a:pPr marL="647700" lvl="1" indent="-323850" algn="l">
               <a:lnSpc>
-                <a:spcPts val="6000"/>
+                <a:spcPct val="150000"/>
               </a:lnSpc>
               <a:buFont typeface="Arial"/>
               <a:buChar char="•"/>
             </a:pPr>
             <a:r>
-              <a:rPr lang="en-US" sz="3000">
-                <a:solidFill>
-                  <a:srgbClr val="000000"/>
-                </a:solidFill>
-                <a:latin typeface="Barlow"/>
-                <a:ea typeface="Barlow"/>
-                <a:cs typeface="Barlow"/>
-                <a:sym typeface="Barlow"/>
-              </a:rPr>
-              <a:t>Resize: 640 × 640 pixels</a:t>
-            </a:r>
-          </a:p>
-          <a:p>
-            <a:pPr marL="647700" lvl="1" indent="-323850" algn="l">
-              <a:lnSpc>
-                <a:spcPts val="6000"/>
-              </a:lnSpc>
-              <a:buFont typeface="Arial"/>
-              <a:buChar char="•"/>
-            </a:pPr>
-            <a:r>
-              <a:rPr lang="en-US" sz="3000">
+              <a:rPr lang="en-US" sz="2000" dirty="0">
                 <a:solidFill>
                   <a:srgbClr val="000000"/>
                 </a:solidFill>
@@ -12185,13 +12324,13 @@
           <a:p>
             <a:pPr marL="647700" lvl="1" indent="-323850" algn="l">
               <a:lnSpc>
-                <a:spcPts val="6000"/>
+                <a:spcPct val="150000"/>
               </a:lnSpc>
               <a:buFont typeface="Arial"/>
               <a:buChar char="•"/>
             </a:pPr>
             <a:r>
-              <a:rPr lang="en-US" sz="3000">
+              <a:rPr lang="en-US" sz="2000" dirty="0">
                 <a:solidFill>
                   <a:srgbClr val="000000"/>
                 </a:solidFill>
@@ -14755,8 +14894,8 @@
           </a:p>
         </p:txBody>
       </p:sp>
-      <mc:AlternateContent xmlns:mc="http://schemas.openxmlformats.org/markup-compatibility/2006" xmlns:a14="http://schemas.microsoft.com/office/drawing/2010/main">
-        <mc:Choice Requires="a14">
+      <mc:AlternateContent xmlns:mc="http://schemas.openxmlformats.org/markup-compatibility/2006">
+        <mc:Choice xmlns:a14="http://schemas.microsoft.com/office/drawing/2010/main" Requires="a14">
           <p:graphicFrame>
             <p:nvGraphicFramePr>
               <p:cNvPr id="11" name="Table 10">
@@ -14772,7 +14911,7 @@
               <p:nvPr>
                 <p:extLst>
                   <p:ext uri="{D42A27DB-BD31-4B8C-83A1-F6EECF244321}">
-                    <p14:modId xmlns:p14="http://schemas.microsoft.com/office/powerpoint/2010/main" val="3520048227"/>
+                    <p14:modId xmlns:p14="http://schemas.microsoft.com/office/powerpoint/2010/main" val="167160632"/>
                   </p:ext>
                 </p:extLst>
               </p:nvPr>
@@ -15267,7 +15406,15 @@
                           </a14:m>
                           <a:r>
                             <a:rPr lang="vi-VN" sz="2800" dirty="0"/>
-                            <a:t>0/99</a:t>
+                            <a:t>0</a:t>
+                          </a:r>
+                          <a:r>
+                            <a:rPr lang="en-US" sz="2800" dirty="0"/>
+                            <a:t>.</a:t>
+                          </a:r>
+                          <a:r>
+                            <a:rPr lang="vi-VN" sz="2800" dirty="0"/>
+                            <a:t>99</a:t>
                           </a:r>
                         </a:p>
                       </a:txBody>
@@ -15475,7 +15622,7 @@
             </a:graphic>
           </p:graphicFrame>
         </mc:Choice>
-        <mc:Fallback xmlns="">
+        <mc:Fallback>
           <p:graphicFrame>
             <p:nvGraphicFramePr>
               <p:cNvPr id="11" name="Table 10">
@@ -15491,7 +15638,7 @@
               <p:nvPr>
                 <p:extLst>
                   <p:ext uri="{D42A27DB-BD31-4B8C-83A1-F6EECF244321}">
-                    <p14:modId xmlns:p14="http://schemas.microsoft.com/office/powerpoint/2010/main" val="3520048227"/>
+                    <p14:modId xmlns:p14="http://schemas.microsoft.com/office/powerpoint/2010/main" val="167160632"/>
                   </p:ext>
                 </p:extLst>
               </p:nvPr>

</xml_diff>